<commit_message>
docs(ti): corregir titulos de los 4 ERS e incorporar documentos finales de los talleres TI.1 (TI.1.1 a TI.1.4)
</commit_message>
<xml_diff>
--- a/TI.1.1. PAO202651_SOAP_JAVA_SINBDD_NRC36884_GR09/05. DOCUMENTACION/CONVUNI_SOAP_JAVA_GR09.pptx
+++ b/TI.1.1. PAO202651_SOAP_JAVA_SINBDD_NRC36884_GR09/05. DOCUMENTACION/CONVUNI_SOAP_JAVA_GR09.pptx
@@ -18386,7 +18386,7 @@
                   <a:schemeClr val="lt1"/>
                 </a:solidFill>
               </a:rPr>
-              <a:t>INTEGRANTE:</a:t>
+              <a:t>INTEGRANTES:</a:t>
             </a:r>
           </a:p>
           <a:p>
@@ -18410,6 +18410,27 @@
                 </a:solidFill>
               </a:rPr>
               <a:t>JULIO ENRIQUE VICHE CASTILLO</a:t>
+            </a:r>
+          </a:p>
+          <a:p>
+            <a:pPr marL="0" lvl="0" indent="0" algn="l" rtl="0">
+              <a:lnSpc>
+                <a:spcPct val="100000"/>
+              </a:lnSpc>
+              <a:spcBef>
+                <a:spcPts val="0"/>
+              </a:spcBef>
+              <a:spcAft>
+                <a:spcPts val="0"/>
+              </a:spcAft>
+            </a:pPr>
+            <a:r>
+              <a:rPr lang="es-ES" b="1">
+                <a:solidFill>
+                  <a:schemeClr val="lt1"/>
+                </a:solidFill>
+              </a:rPr>
+              <a:t>GABRIEL OMAR MURILLO MEDINA</a:t>
             </a:r>
           </a:p>
           <a:p>

</xml_diff>

<commit_message>
chore: guardar avances SOAP y contexto de continuacion
Guarda los cambios de documentos TI1.1/TI1.2 y el descriptor de Payara. Registra las pruebas temporales, los errores detectados y la auditoria pendiente de TI1.2; no declara terminada la correccion.
</commit_message>
<xml_diff>
--- a/TI.1.1. PAO202651_SOAP_JAVA_SINBDD_NRC36884_GR09/05. DOCUMENTACION/CONVUNI_SOAP_JAVA_GR09.pptx
+++ b/TI.1.1. PAO202651_SOAP_JAVA_SINBDD_NRC36884_GR09/05. DOCUMENTACION/CONVUNI_SOAP_JAVA_GR09.pptx
@@ -31954,14 +31954,15 @@
         </p:nvPicPr>
         <p:blipFill>
           <a:blip r:embed="rId3"/>
+          <a:srcRect t="1000" b="30000"/>
           <a:stretch>
             <a:fillRect/>
           </a:stretch>
         </p:blipFill>
         <p:spPr>
           <a:xfrm>
-            <a:off x="6067748" y="3395466"/>
-            <a:ext cx="1404564" cy="3121254"/>
+            <a:off x="5669280" y="3593592"/>
+            <a:ext cx="1818861" cy="2788920"/>
           </a:xfrm>
           <a:prstGeom prst="rect">
             <a:avLst/>
@@ -31978,14 +31979,15 @@
         </p:nvPicPr>
         <p:blipFill>
           <a:blip r:embed="rId4"/>
+          <a:srcRect t="16000" b="28000"/>
           <a:stretch>
             <a:fillRect/>
           </a:stretch>
         </p:blipFill>
         <p:spPr>
           <a:xfrm>
-            <a:off x="1932009" y="3523400"/>
-            <a:ext cx="1030616" cy="2290259"/>
+            <a:off x="1508760" y="3593592"/>
+            <a:ext cx="2241096" cy="2788920"/>
           </a:xfrm>
           <a:prstGeom prst="rect">
             <a:avLst/>
@@ -32604,14 +32606,15 @@
         </p:nvPicPr>
         <p:blipFill>
           <a:blip r:embed="rId3"/>
+          <a:srcRect t="1000" b="30000"/>
           <a:stretch>
             <a:fillRect/>
           </a:stretch>
         </p:blipFill>
         <p:spPr>
           <a:xfrm>
-            <a:off x="2186915" y="3132225"/>
-            <a:ext cx="1561387" cy="3469750"/>
+            <a:off x="1097280" y="2907792"/>
+            <a:ext cx="2295939" cy="3520440"/>
           </a:xfrm>
           <a:prstGeom prst="rect">
             <a:avLst/>
@@ -32634,14 +32637,15 @@
               </a:ext>
             </a:extLst>
           </a:blip>
+          <a:srcRect t="16000" b="28000"/>
           <a:stretch>
             <a:fillRect/>
           </a:stretch>
         </p:blipFill>
         <p:spPr>
           <a:xfrm>
-            <a:off x="4375360" y="3132224"/>
-            <a:ext cx="1577205" cy="3469750"/>
+            <a:off x="4937760" y="2907792"/>
+            <a:ext cx="2828925" cy="3520440"/>
           </a:xfrm>
           <a:prstGeom prst="rect">
             <a:avLst/>
@@ -38049,8 +38053,8 @@
         </p:blipFill>
         <p:spPr>
           <a:xfrm>
-            <a:off x="2961150" y="4519592"/>
-            <a:ext cx="2761232" cy="1963673"/>
+            <a:off x="320040" y="2423160"/>
+            <a:ext cx="2770632" cy="1783080"/>
           </a:xfrm>
           <a:prstGeom prst="rect">
             <a:avLst/>
@@ -38073,8 +38077,8 @@
         </p:blipFill>
         <p:spPr>
           <a:xfrm>
-            <a:off x="330934" y="4484349"/>
-            <a:ext cx="2630216" cy="1870500"/>
+            <a:off x="3246120" y="2423160"/>
+            <a:ext cx="2770632" cy="1783080"/>
           </a:xfrm>
           <a:prstGeom prst="rect">
             <a:avLst/>
@@ -38097,8 +38101,8 @@
         </p:blipFill>
         <p:spPr>
           <a:xfrm>
-            <a:off x="4671319" y="2018936"/>
-            <a:ext cx="2849245" cy="2026264"/>
+            <a:off x="6172200" y="2423160"/>
+            <a:ext cx="2770632" cy="1783080"/>
           </a:xfrm>
           <a:prstGeom prst="rect">
             <a:avLst/>
@@ -38121,8 +38125,8 @@
         </p:blipFill>
         <p:spPr>
           <a:xfrm>
-            <a:off x="1622424" y="2724790"/>
-            <a:ext cx="1891543" cy="1345186"/>
+            <a:off x="1783080" y="4434840"/>
+            <a:ext cx="2770632" cy="1783080"/>
           </a:xfrm>
           <a:prstGeom prst="rect">
             <a:avLst/>
@@ -38144,8 +38148,8 @@
         </p:blipFill>
         <p:spPr>
           <a:xfrm>
-            <a:off x="4800000" y="3900000"/>
-            <a:ext cx="4200000" cy="2600000"/>
+            <a:off x="4709160" y="4434840"/>
+            <a:ext cx="2770632" cy="1783080"/>
           </a:xfrm>
           <a:prstGeom prst="rect">
             <a:avLst/>

</xml_diff>